<commit_message>
Cut the redundant "national reach / global reach" slogan on the title slide
Slide 1 had drifted into stating the scale ambition four times over
(eyebrow, body, byline, tag). The tag line -- "National reach today.
Global reach ahead." -- was the worst of it: a throwaway parallel-clause
slogan that just restated the body paragraph in weaker words, and read
as generic AI-pitch-deck filler rather than something a real company
would print.

Fixed: the body paragraph now states the scale ambition once, in plain
prose ("...a platform Varaxis is scaling nationally, then
internationally"), and the tag under the byline became a one-line sector
category ("Healthcare Technology") instead of repeating it. Varaxis is
still named in the eyebrow and the byline, which is normal for a cover
slide's running header/footer, not prose repetition.

Co-Authored-By: Claude Sonnet 5 <noreply@anthropic.com>
</commit_message>
<xml_diff>
--- a/artifacts/ClinicOS_DesignThinking_Deck.pptx
+++ b/artifacts/ClinicOS_DesignThinking_Deck.pptx
@@ -2616,7 +2616,7 @@
                 <a:ea typeface="Calibri" pitchFamily="34" charset="-122"/>
                 <a:cs typeface="Calibri" pitchFamily="34" charset="-120"/>
               </a:rPr>
-              <a:t>Built by Varaxis to work at the scale of the whole country, and in time, beyond it — this design-thinking case study traces the evidence back to where it started: a single-doctor rural clinic, one room, one doctor, one register.</a:t>
+              <a:t>A design-thinking case study that starts with a single-doctor rural clinic — one room, one doctor, one register — and follows the evidence toward a platform Varaxis is scaling nationally, then internationally.</a:t>
             </a:r>
             <a:endParaRPr lang="en-US" sz="1450" dirty="0"/>
           </a:p>
@@ -2694,7 +2694,7 @@
                 <a:ea typeface="Calibri" pitchFamily="34" charset="-122"/>
                 <a:cs typeface="Calibri" pitchFamily="34" charset="-120"/>
               </a:rPr>
-              <a:t>National reach today. Global reach ahead.</a:t>
+              <a:t>Healthcare Technology</a:t>
             </a:r>
             <a:endParaRPr lang="en-US" sz="1200" dirty="0"/>
           </a:p>

</xml_diff>

<commit_message>
Reframe the design-thinking report and deck: clinics to health systems
The report and deck now follow the original plan — single-doctor clinics,
then multi-doctor clinics, hospitals and health systems, then
international — with no field-site town or rural starting point. The
report gains a second persona for a larger institution, a scaling-path
section, and prescription and receipt screenshots without the old
address.

Co-Authored-By: Claude Opus 5.5 <noreply@anthropic.com>
Claude-Session: https://claude.ai/code/session_012tam43Wrx3VFhnLz3rDLzg
</commit_message>
<xml_diff>
--- a/artifacts/ClinicOS_DesignThinking_Deck.pptx
+++ b/artifacts/ClinicOS_DesignThinking_Deck.pptx
@@ -2616,7 +2616,7 @@
                 <a:ea typeface="Calibri" pitchFamily="34" charset="-122"/>
                 <a:cs typeface="Calibri" pitchFamily="34" charset="-120"/>
               </a:rPr>
-              <a:t>A design-thinking case study that starts with a single-doctor rural clinic — one room, one doctor, one register — and follows the evidence toward a platform Varaxis is scaling nationally, then internationally.</a:t>
+              <a:t>A design-thinking case study of one product built to grow: from the single-doctor clinic to multi-doctor clinics, hospitals and health systems, and then internationally.</a:t>
             </a:r>
             <a:endParaRPr lang="en-US" sz="1450" dirty="0"/>
           </a:p>
@@ -3129,6 +3129,10 @@
             <a:prstDash val="solid"/>
           </a:ln>
         </p:spPr>
+        <p:txBody>
+          <a:bodyPr/>
+          <a:p/>
+        </p:txBody>
       </p:sp>
       <p:sp>
         <p:nvSpPr>
@@ -3188,6 +3192,10 @@
           </a:solidFill>
           <a:ln/>
         </p:spPr>
+        <p:txBody>
+          <a:bodyPr/>
+          <a:p/>
+        </p:txBody>
       </p:sp>
       <p:sp>
         <p:nvSpPr>
@@ -3208,6 +3216,10 @@
           </a:solidFill>
           <a:ln/>
         </p:spPr>
+        <p:txBody>
+          <a:bodyPr/>
+          <a:p/>
+        </p:txBody>
       </p:sp>
       <p:sp>
         <p:nvSpPr>
@@ -3228,6 +3240,10 @@
           </a:solidFill>
           <a:ln/>
         </p:spPr>
+        <p:txBody>
+          <a:bodyPr/>
+          <a:p/>
+        </p:txBody>
       </p:sp>
       <p:sp>
         <p:nvSpPr>
@@ -3248,6 +3264,10 @@
           </a:solidFill>
           <a:ln/>
         </p:spPr>
+        <p:txBody>
+          <a:bodyPr/>
+          <a:p/>
+        </p:txBody>
       </p:sp>
       <p:sp>
         <p:nvSpPr>
@@ -3268,6 +3288,10 @@
           </a:solidFill>
           <a:ln/>
         </p:spPr>
+        <p:txBody>
+          <a:bodyPr/>
+          <a:p/>
+        </p:txBody>
       </p:sp>
       <p:sp>
         <p:nvSpPr>
@@ -3344,7 +3368,7 @@
                 <a:ea typeface="Cambria" pitchFamily="34" charset="-122"/>
                 <a:cs typeface="Cambria" pitchFamily="34" charset="-120"/>
               </a:rPr>
-              <a:t>In single-doctor rural clinics, a consultation lasting roughly two minutes must produce both care and a record — and the record is routinely the part sacrificed. Existing software answers this by asking the doctor to type during the visit, which measurably consumes more clinical attention than paper does, and is abandoned. Clinics are left with no usable history, unsystematic follow-up, and years of records resting on a single register or a single laptop.</a:t>
+              <a:t>In busy outpatient practice — starting with the single-doctor clinic — a consultation lasting roughly two minutes must produce both care and a record, and the record is routinely the part sacrificed. Existing software answers this by asking the doctor to type during the visit, which measurably consumes more clinical attention than paper does, and is abandoned. Clinics are left with no usable history, unsystematic follow-up, and years of records resting on a single register or a single laptop.</a:t>
             </a:r>
             <a:endParaRPr lang="en-US" sz="2500" dirty="0"/>
           </a:p>
@@ -3372,6 +3396,10 @@
             <a:prstDash val="solid"/>
           </a:ln>
         </p:spPr>
+        <p:txBody>
+          <a:bodyPr/>
+          <a:p/>
+        </p:txBody>
       </p:sp>
       <p:sp>
         <p:nvSpPr>
@@ -3464,6 +3492,10 @@
             <a:prstDash val="solid"/>
           </a:ln>
         </p:spPr>
+        <p:txBody>
+          <a:bodyPr/>
+          <a:p/>
+        </p:txBody>
       </p:sp>
       <p:sp>
         <p:nvSpPr>
@@ -3601,6 +3633,10 @@
           </a:solidFill>
           <a:ln/>
         </p:spPr>
+        <p:txBody>
+          <a:bodyPr/>
+          <a:p/>
+        </p:txBody>
       </p:sp>
       <p:sp>
         <p:nvSpPr>
@@ -3621,6 +3657,10 @@
           </a:solidFill>
           <a:ln/>
         </p:spPr>
+        <p:txBody>
+          <a:bodyPr/>
+          <a:p/>
+        </p:txBody>
       </p:sp>
       <p:sp>
         <p:nvSpPr>
@@ -3641,6 +3681,10 @@
           </a:solidFill>
           <a:ln/>
         </p:spPr>
+        <p:txBody>
+          <a:bodyPr/>
+          <a:p/>
+        </p:txBody>
       </p:sp>
       <p:sp>
         <p:nvSpPr>
@@ -3661,6 +3705,10 @@
           </a:solidFill>
           <a:ln/>
         </p:spPr>
+        <p:txBody>
+          <a:bodyPr/>
+          <a:p/>
+        </p:txBody>
       </p:sp>
       <p:sp>
         <p:nvSpPr>
@@ -3681,6 +3729,10 @@
           </a:solidFill>
           <a:ln/>
         </p:spPr>
+        <p:txBody>
+          <a:bodyPr/>
+          <a:p/>
+        </p:txBody>
       </p:sp>
       <p:sp>
         <p:nvSpPr>
@@ -3703,6 +3755,10 @@
           </a:solidFill>
           <a:ln/>
         </p:spPr>
+        <p:txBody>
+          <a:bodyPr/>
+          <a:p/>
+        </p:txBody>
       </p:sp>
       <p:sp>
         <p:nvSpPr>
@@ -3857,6 +3913,10 @@
             </a:outerShdw>
           </a:effectLst>
         </p:spPr>
+        <p:txBody>
+          <a:bodyPr/>
+          <a:p/>
+        </p:txBody>
       </p:sp>
       <p:sp>
         <p:nvSpPr>
@@ -3972,6 +4032,10 @@
             </a:outerShdw>
           </a:effectLst>
         </p:spPr>
+        <p:txBody>
+          <a:bodyPr/>
+          <a:p/>
+        </p:txBody>
       </p:sp>
       <p:sp>
         <p:nvSpPr>
@@ -4087,6 +4151,10 @@
             </a:outerShdw>
           </a:effectLst>
         </p:spPr>
+        <p:txBody>
+          <a:bodyPr/>
+          <a:p/>
+        </p:txBody>
       </p:sp>
       <p:sp>
         <p:nvSpPr>
@@ -4202,6 +4270,10 @@
             </a:outerShdw>
           </a:effectLst>
         </p:spPr>
+        <p:txBody>
+          <a:bodyPr/>
+          <a:p/>
+        </p:txBody>
       </p:sp>
       <p:sp>
         <p:nvSpPr>
@@ -5588,6 +5660,10 @@
             <a:prstDash val="solid"/>
           </a:ln>
         </p:spPr>
+        <p:txBody>
+          <a:bodyPr/>
+          <a:p/>
+        </p:txBody>
       </p:sp>
       <p:sp>
         <p:nvSpPr>
@@ -5725,6 +5801,10 @@
           </a:solidFill>
           <a:ln/>
         </p:spPr>
+        <p:txBody>
+          <a:bodyPr/>
+          <a:p/>
+        </p:txBody>
       </p:sp>
       <p:sp>
         <p:nvSpPr>
@@ -5745,6 +5825,10 @@
           </a:solidFill>
           <a:ln/>
         </p:spPr>
+        <p:txBody>
+          <a:bodyPr/>
+          <a:p/>
+        </p:txBody>
       </p:sp>
       <p:sp>
         <p:nvSpPr>
@@ -5765,6 +5849,10 @@
           </a:solidFill>
           <a:ln/>
         </p:spPr>
+        <p:txBody>
+          <a:bodyPr/>
+          <a:p/>
+        </p:txBody>
       </p:sp>
       <p:sp>
         <p:nvSpPr>
@@ -5785,6 +5873,10 @@
           </a:solidFill>
           <a:ln/>
         </p:spPr>
+        <p:txBody>
+          <a:bodyPr/>
+          <a:p/>
+        </p:txBody>
       </p:sp>
       <p:sp>
         <p:nvSpPr>
@@ -5805,6 +5897,10 @@
           </a:solidFill>
           <a:ln/>
         </p:spPr>
+        <p:txBody>
+          <a:bodyPr/>
+          <a:p/>
+        </p:txBody>
       </p:sp>
       <p:sp>
         <p:nvSpPr>
@@ -5832,6 +5928,10 @@
             <a:prstDash val="solid"/>
           </a:ln>
         </p:spPr>
+        <p:txBody>
+          <a:bodyPr/>
+          <a:p/>
+        </p:txBody>
       </p:sp>
       <p:sp>
         <p:nvSpPr>
@@ -5852,6 +5952,10 @@
           </a:solidFill>
           <a:ln/>
         </p:spPr>
+        <p:txBody>
+          <a:bodyPr/>
+          <a:p/>
+        </p:txBody>
       </p:sp>
       <p:sp>
         <p:nvSpPr>
@@ -5999,6 +6103,10 @@
             <a:prstDash val="solid"/>
           </a:ln>
         </p:spPr>
+        <p:txBody>
+          <a:bodyPr/>
+          <a:p/>
+        </p:txBody>
       </p:sp>
       <p:sp>
         <p:nvSpPr>
@@ -6019,6 +6127,10 @@
           </a:solidFill>
           <a:ln/>
         </p:spPr>
+        <p:txBody>
+          <a:bodyPr/>
+          <a:p/>
+        </p:txBody>
       </p:sp>
       <p:sp>
         <p:nvSpPr>
@@ -6166,6 +6278,10 @@
             <a:prstDash val="solid"/>
           </a:ln>
         </p:spPr>
+        <p:txBody>
+          <a:bodyPr/>
+          <a:p/>
+        </p:txBody>
       </p:sp>
       <p:sp>
         <p:nvSpPr>
@@ -6186,6 +6302,10 @@
           </a:solidFill>
           <a:ln/>
         </p:spPr>
+        <p:txBody>
+          <a:bodyPr/>
+          <a:p/>
+        </p:txBody>
       </p:sp>
       <p:sp>
         <p:nvSpPr>
@@ -6335,6 +6455,10 @@
             </a:outerShdw>
           </a:effectLst>
         </p:spPr>
+        <p:txBody>
+          <a:bodyPr/>
+          <a:p/>
+        </p:txBody>
       </p:sp>
       <p:sp>
         <p:nvSpPr>
@@ -6355,6 +6479,10 @@
           </a:solidFill>
           <a:ln/>
         </p:spPr>
+        <p:txBody>
+          <a:bodyPr/>
+          <a:p/>
+        </p:txBody>
       </p:sp>
       <p:sp>
         <p:nvSpPr>
@@ -6564,6 +6692,10 @@
             <a:prstDash val="solid"/>
           </a:ln>
         </p:spPr>
+        <p:txBody>
+          <a:bodyPr/>
+          <a:p/>
+        </p:txBody>
       </p:sp>
       <p:sp>
         <p:nvSpPr>
@@ -6701,6 +6833,10 @@
           </a:solidFill>
           <a:ln/>
         </p:spPr>
+        <p:txBody>
+          <a:bodyPr/>
+          <a:p/>
+        </p:txBody>
       </p:sp>
       <p:sp>
         <p:nvSpPr>
@@ -6721,6 +6857,10 @@
           </a:solidFill>
           <a:ln/>
         </p:spPr>
+        <p:txBody>
+          <a:bodyPr/>
+          <a:p/>
+        </p:txBody>
       </p:sp>
       <p:sp>
         <p:nvSpPr>
@@ -6741,6 +6881,10 @@
           </a:solidFill>
           <a:ln/>
         </p:spPr>
+        <p:txBody>
+          <a:bodyPr/>
+          <a:p/>
+        </p:txBody>
       </p:sp>
       <p:sp>
         <p:nvSpPr>
@@ -6761,6 +6905,10 @@
           </a:solidFill>
           <a:ln/>
         </p:spPr>
+        <p:txBody>
+          <a:bodyPr/>
+          <a:p/>
+        </p:txBody>
       </p:sp>
       <p:sp>
         <p:nvSpPr>
@@ -6781,6 +6929,10 @@
           </a:solidFill>
           <a:ln/>
         </p:spPr>
+        <p:txBody>
+          <a:bodyPr/>
+          <a:p/>
+        </p:txBody>
       </p:sp>
       <p:sp>
         <p:nvSpPr>
@@ -6854,6 +7006,10 @@
             </a:outerShdw>
           </a:effectLst>
         </p:spPr>
+        <p:txBody>
+          <a:bodyPr/>
+          <a:p/>
+        </p:txBody>
       </p:sp>
       <p:sp>
         <p:nvSpPr>
@@ -6874,6 +7030,10 @@
           </a:solidFill>
           <a:ln/>
         </p:spPr>
+        <p:txBody>
+          <a:bodyPr/>
+          <a:p/>
+        </p:txBody>
       </p:sp>
       <p:pic>
         <p:nvPicPr>
@@ -7011,6 +7171,10 @@
             </a:outerShdw>
           </a:effectLst>
         </p:spPr>
+        <p:txBody>
+          <a:bodyPr/>
+          <a:p/>
+        </p:txBody>
       </p:sp>
       <p:sp>
         <p:nvSpPr>
@@ -7031,6 +7195,10 @@
           </a:solidFill>
           <a:ln/>
         </p:spPr>
+        <p:txBody>
+          <a:bodyPr/>
+          <a:p/>
+        </p:txBody>
       </p:sp>
       <p:pic>
         <p:nvPicPr>
@@ -7173,6 +7341,10 @@
             </a:outerShdw>
           </a:effectLst>
         </p:spPr>
+        <p:txBody>
+          <a:bodyPr/>
+          <a:p/>
+        </p:txBody>
       </p:sp>
       <p:sp>
         <p:nvSpPr>
@@ -7193,6 +7365,10 @@
           </a:solidFill>
           <a:ln/>
         </p:spPr>
+        <p:txBody>
+          <a:bodyPr/>
+          <a:p/>
+        </p:txBody>
       </p:sp>
       <p:pic>
         <p:nvPicPr>
@@ -7335,6 +7511,10 @@
             </a:outerShdw>
           </a:effectLst>
         </p:spPr>
+        <p:txBody>
+          <a:bodyPr/>
+          <a:p/>
+        </p:txBody>
       </p:sp>
       <p:sp>
         <p:nvSpPr>
@@ -7355,6 +7535,10 @@
           </a:solidFill>
           <a:ln/>
         </p:spPr>
+        <p:txBody>
+          <a:bodyPr/>
+          <a:p/>
+        </p:txBody>
       </p:sp>
       <p:pic>
         <p:nvPicPr>
@@ -7513,6 +7697,10 @@
             <a:prstDash val="solid"/>
           </a:ln>
         </p:spPr>
+        <p:txBody>
+          <a:bodyPr/>
+          <a:p/>
+        </p:txBody>
       </p:sp>
       <p:sp>
         <p:nvSpPr>
@@ -7650,6 +7838,10 @@
           </a:solidFill>
           <a:ln/>
         </p:spPr>
+        <p:txBody>
+          <a:bodyPr/>
+          <a:p/>
+        </p:txBody>
       </p:sp>
       <p:sp>
         <p:nvSpPr>
@@ -7670,6 +7862,10 @@
           </a:solidFill>
           <a:ln/>
         </p:spPr>
+        <p:txBody>
+          <a:bodyPr/>
+          <a:p/>
+        </p:txBody>
       </p:sp>
       <p:sp>
         <p:nvSpPr>
@@ -7690,6 +7886,10 @@
           </a:solidFill>
           <a:ln/>
         </p:spPr>
+        <p:txBody>
+          <a:bodyPr/>
+          <a:p/>
+        </p:txBody>
       </p:sp>
       <p:sp>
         <p:nvSpPr>
@@ -7710,6 +7910,10 @@
           </a:solidFill>
           <a:ln/>
         </p:spPr>
+        <p:txBody>
+          <a:bodyPr/>
+          <a:p/>
+        </p:txBody>
       </p:sp>
       <p:sp>
         <p:nvSpPr>
@@ -7730,6 +7934,10 @@
           </a:solidFill>
           <a:ln/>
         </p:spPr>
+        <p:txBody>
+          <a:bodyPr/>
+          <a:p/>
+        </p:txBody>
       </p:sp>
       <p:pic>
         <p:nvPicPr>
@@ -8135,6 +8343,10 @@
             <a:prstDash val="solid"/>
           </a:ln>
         </p:spPr>
+        <p:txBody>
+          <a:bodyPr/>
+          <a:p/>
+        </p:txBody>
       </p:sp>
       <p:sp>
         <p:nvSpPr>
@@ -8272,6 +8484,10 @@
           </a:solidFill>
           <a:ln/>
         </p:spPr>
+        <p:txBody>
+          <a:bodyPr/>
+          <a:p/>
+        </p:txBody>
       </p:sp>
       <p:sp>
         <p:nvSpPr>
@@ -8292,6 +8508,10 @@
           </a:solidFill>
           <a:ln/>
         </p:spPr>
+        <p:txBody>
+          <a:bodyPr/>
+          <a:p/>
+        </p:txBody>
       </p:sp>
       <p:sp>
         <p:nvSpPr>
@@ -8312,6 +8532,10 @@
           </a:solidFill>
           <a:ln/>
         </p:spPr>
+        <p:txBody>
+          <a:bodyPr/>
+          <a:p/>
+        </p:txBody>
       </p:sp>
       <p:sp>
         <p:nvSpPr>
@@ -8332,6 +8556,10 @@
           </a:solidFill>
           <a:ln/>
         </p:spPr>
+        <p:txBody>
+          <a:bodyPr/>
+          <a:p/>
+        </p:txBody>
       </p:sp>
       <p:sp>
         <p:nvSpPr>
@@ -8352,6 +8580,10 @@
           </a:solidFill>
           <a:ln/>
         </p:spPr>
+        <p:txBody>
+          <a:bodyPr/>
+          <a:p/>
+        </p:txBody>
       </p:sp>
       <p:pic>
         <p:nvPicPr>
@@ -8490,6 +8722,10 @@
             </a:outerShdw>
           </a:effectLst>
         </p:spPr>
+        <p:txBody>
+          <a:bodyPr/>
+          <a:p/>
+        </p:txBody>
       </p:sp>
       <p:sp>
         <p:nvSpPr>
@@ -8593,6 +8829,10 @@
           </a:solidFill>
           <a:ln/>
         </p:spPr>
+        <p:txBody>
+          <a:bodyPr/>
+          <a:p/>
+        </p:txBody>
       </p:sp>
       <p:sp>
         <p:nvSpPr>
@@ -8696,6 +8936,10 @@
           </a:solidFill>
           <a:ln/>
         </p:spPr>
+        <p:txBody>
+          <a:bodyPr/>
+          <a:p/>
+        </p:txBody>
       </p:sp>
       <p:sp>
         <p:nvSpPr>
@@ -8827,6 +9071,10 @@
             <a:prstDash val="solid"/>
           </a:ln>
         </p:spPr>
+        <p:txBody>
+          <a:bodyPr/>
+          <a:p/>
+        </p:txBody>
       </p:sp>
       <p:sp>
         <p:nvSpPr>
@@ -8964,6 +9212,10 @@
           </a:solidFill>
           <a:ln/>
         </p:spPr>
+        <p:txBody>
+          <a:bodyPr/>
+          <a:p/>
+        </p:txBody>
       </p:sp>
       <p:sp>
         <p:nvSpPr>
@@ -8984,6 +9236,10 @@
           </a:solidFill>
           <a:ln/>
         </p:spPr>
+        <p:txBody>
+          <a:bodyPr/>
+          <a:p/>
+        </p:txBody>
       </p:sp>
       <p:sp>
         <p:nvSpPr>
@@ -9004,6 +9260,10 @@
           </a:solidFill>
           <a:ln/>
         </p:spPr>
+        <p:txBody>
+          <a:bodyPr/>
+          <a:p/>
+        </p:txBody>
       </p:sp>
       <p:sp>
         <p:nvSpPr>
@@ -9024,6 +9284,10 @@
           </a:solidFill>
           <a:ln/>
         </p:spPr>
+        <p:txBody>
+          <a:bodyPr/>
+          <a:p/>
+        </p:txBody>
       </p:sp>
       <p:sp>
         <p:nvSpPr>
@@ -9044,6 +9308,10 @@
           </a:solidFill>
           <a:ln/>
         </p:spPr>
+        <p:txBody>
+          <a:bodyPr/>
+          <a:p/>
+        </p:txBody>
       </p:sp>
       <p:sp>
         <p:nvSpPr>
@@ -9117,6 +9385,10 @@
             </a:outerShdw>
           </a:effectLst>
         </p:spPr>
+        <p:txBody>
+          <a:bodyPr/>
+          <a:p/>
+        </p:txBody>
       </p:sp>
       <p:sp>
         <p:nvSpPr>
@@ -9313,6 +9585,10 @@
             </a:outerShdw>
           </a:effectLst>
         </p:spPr>
+        <p:txBody>
+          <a:bodyPr/>
+          <a:p/>
+        </p:txBody>
       </p:sp>
       <p:sp>
         <p:nvSpPr>
@@ -9504,6 +9780,10 @@
             </a:outerShdw>
           </a:effectLst>
         </p:spPr>
+        <p:txBody>
+          <a:bodyPr/>
+          <a:p/>
+        </p:txBody>
       </p:sp>
       <p:sp>
         <p:nvSpPr>
@@ -9688,6 +9968,10 @@
           </a:solidFill>
           <a:ln/>
         </p:spPr>
+        <p:txBody>
+          <a:bodyPr/>
+          <a:p/>
+        </p:txBody>
       </p:sp>
       <p:sp>
         <p:nvSpPr>
@@ -9850,7 +10134,7 @@
                 <a:ea typeface="Cambria" pitchFamily="34" charset="-122"/>
                 <a:cs typeface="Cambria" pitchFamily="34" charset="-120"/>
               </a:rPr>
-              <a:t>One room first. Built for the country.</a:t>
+              <a:t>Clinics first. Then the world.</a:t>
             </a:r>
             <a:endParaRPr lang="en-US" sz="3400" dirty="0"/>
           </a:p>
@@ -10048,7 +10332,7 @@
                 <a:ea typeface="Calibri" pitchFamily="34" charset="-122"/>
                 <a:cs typeface="Calibri" pitchFamily="34" charset="-120"/>
               </a:rPr>
-              <a:t>This began in one rural clinic. ClinicOS is built by Varaxis to scale — nationally, then internationally.</a:t>
+              <a:t>Single-doctor clinics first, then multi-doctor clinics, hospitals and health systems, then international markets.</a:t>
             </a:r>
             <a:endParaRPr lang="en-US" sz="1400" dirty="0"/>
           </a:p>
@@ -11672,7 +11956,7 @@
                 <a:ea typeface="Cambria" pitchFamily="34" charset="-122"/>
                 <a:cs typeface="Cambria" pitchFamily="34" charset="-120"/>
               </a:rPr>
-              <a:t>One room, one doctor, one register</a:t>
+              <a:t>One consultation, every size of institution</a:t>
             </a:r>
             <a:endParaRPr lang="en-US" sz="3400" dirty="0"/>
           </a:p>
@@ -11714,7 +11998,7 @@
                 <a:ea typeface="Calibri" pitchFamily="34" charset="-122"/>
                 <a:cs typeface="Calibri" pitchFamily="34" charset="-120"/>
               </a:rPr>
-              <a:t>Indian rural primary care runs on very small units. Alongside the public network of health centres sits a far larger, largely uncounted layer of private single-doctor chambers: one room, one doctor, a paper register and a queue outside.</a:t>
+              <a:t>Outpatient care runs under time pressure everywhere, and in India it is extreme. Patients are seen in public health centres, private solo chambers, multi-doctor clinics and hospital outpatient departments — the same short consultation in every one.</a:t>
             </a:r>
             <a:endParaRPr lang="en-US" sz="1500" dirty="0"/>
           </a:p>
@@ -11756,7 +12040,7 @@
                 <a:ea typeface="Calibri" pitchFamily="34" charset="-122"/>
                 <a:cs typeface="Calibri" pitchFamily="34" charset="-120"/>
               </a:rPr>
-              <a:t>That chamber is the unit this project studies — it is where the largest number of Indian patients are seen, and almost no clinical software is built for it. It is also where Varaxis's national ambitions for this product begin.</a:t>
+              <a:t>The unit this project studies is the consultation itself. It starts with the single-doctor clinic, where the whole visit rests on one person, and grows into multi-doctor clinics, hospitals and health systems.</a:t>
             </a:r>
             <a:endParaRPr lang="en-US" sz="1500" dirty="0"/>
           </a:p>
@@ -11795,7 +12079,7 @@
                 <a:ea typeface="Calibri" pitchFamily="34" charset="-122"/>
                 <a:cs typeface="Calibri" pitchFamily="34" charset="-120"/>
               </a:rPr>
-              <a:t>Where this began: a single-doctor rural clinic — the starting point, not the limit.</a:t>
+              <a:t>First rung: the single-doctor clinic. Then larger institutions, then international.</a:t>
             </a:r>
             <a:endParaRPr lang="en-US" sz="1250" dirty="0"/>
           </a:p>
@@ -11902,7 +12186,7 @@
                 <a:ea typeface="Calibri" pitchFamily="34" charset="-122"/>
                 <a:cs typeface="Calibri" pitchFamily="34" charset="-120"/>
               </a:rPr>
-              <a:t>Primary Health Centres across rural India</a:t>
+              <a:t>Primary Health Centres across India</a:t>
             </a:r>
             <a:endParaRPr lang="en-US" sz="1250" dirty="0"/>
           </a:p>
@@ -12123,7 +12407,7 @@
                 <a:ea typeface="Calibri" pitchFamily="34" charset="-122"/>
                 <a:cs typeface="Calibri" pitchFamily="34" charset="-120"/>
               </a:rPr>
-              <a:t>doctors per centre — the scale we design for</a:t>
+              <a:t>doctors per public health centre — time is scarce</a:t>
             </a:r>
             <a:endParaRPr lang="en-US" sz="1250" dirty="0"/>
           </a:p>
@@ -12217,6 +12501,10 @@
             <a:prstDash val="solid"/>
           </a:ln>
         </p:spPr>
+        <p:txBody>
+          <a:bodyPr/>
+          <a:p/>
+        </p:txBody>
       </p:sp>
       <p:sp>
         <p:nvSpPr>
@@ -12357,6 +12645,10 @@
             <a:prstDash val="solid"/>
           </a:ln>
         </p:spPr>
+        <p:txBody>
+          <a:bodyPr/>
+          <a:p/>
+        </p:txBody>
       </p:sp>
       <p:sp>
         <p:nvSpPr>
@@ -12389,6 +12681,10 @@
             </a:outerShdw>
           </a:effectLst>
         </p:spPr>
+        <p:txBody>
+          <a:bodyPr/>
+          <a:p/>
+        </p:txBody>
       </p:sp>
       <p:sp>
         <p:nvSpPr>
@@ -12581,6 +12877,10 @@
             </a:outerShdw>
           </a:effectLst>
         </p:spPr>
+        <p:txBody>
+          <a:bodyPr/>
+          <a:p/>
+        </p:txBody>
       </p:sp>
       <p:sp>
         <p:nvSpPr>
@@ -12773,6 +13073,10 @@
             </a:outerShdw>
           </a:effectLst>
         </p:spPr>
+        <p:txBody>
+          <a:bodyPr/>
+          <a:p/>
+        </p:txBody>
       </p:sp>
       <p:sp>
         <p:nvSpPr>
@@ -12965,6 +13269,10 @@
             </a:outerShdw>
           </a:effectLst>
         </p:spPr>
+        <p:txBody>
+          <a:bodyPr/>
+          <a:p/>
+        </p:txBody>
       </p:sp>
       <p:sp>
         <p:nvSpPr>
@@ -13137,6 +13445,10 @@
             </a:outerShdw>
           </a:effectLst>
         </p:spPr>
+        <p:txBody>
+          <a:bodyPr/>
+          <a:p/>
+        </p:txBody>
       </p:sp>
       <p:sp>
         <p:nvSpPr>
@@ -13386,6 +13698,10 @@
             <a:prstDash val="solid"/>
           </a:ln>
         </p:spPr>
+        <p:txBody>
+          <a:bodyPr/>
+          <a:p/>
+        </p:txBody>
       </p:sp>
       <p:sp>
         <p:nvSpPr>
@@ -13523,6 +13839,10 @@
           </a:solidFill>
           <a:ln/>
         </p:spPr>
+        <p:txBody>
+          <a:bodyPr/>
+          <a:p/>
+        </p:txBody>
       </p:sp>
       <p:sp>
         <p:nvSpPr>
@@ -13543,6 +13863,10 @@
           </a:solidFill>
           <a:ln/>
         </p:spPr>
+        <p:txBody>
+          <a:bodyPr/>
+          <a:p/>
+        </p:txBody>
       </p:sp>
       <p:sp>
         <p:nvSpPr>
@@ -13563,6 +13887,10 @@
           </a:solidFill>
           <a:ln/>
         </p:spPr>
+        <p:txBody>
+          <a:bodyPr/>
+          <a:p/>
+        </p:txBody>
       </p:sp>
       <p:sp>
         <p:nvSpPr>
@@ -13583,6 +13911,10 @@
           </a:solidFill>
           <a:ln/>
         </p:spPr>
+        <p:txBody>
+          <a:bodyPr/>
+          <a:p/>
+        </p:txBody>
       </p:sp>
       <p:sp>
         <p:nvSpPr>
@@ -13603,6 +13935,10 @@
           </a:solidFill>
           <a:ln/>
         </p:spPr>
+        <p:txBody>
+          <a:bodyPr/>
+          <a:p/>
+        </p:txBody>
       </p:sp>
       <p:sp>
         <p:nvSpPr>
@@ -13637,6 +13973,10 @@
             </a:outerShdw>
           </a:effectLst>
         </p:spPr>
+        <p:txBody>
+          <a:bodyPr/>
+          <a:p/>
+        </p:txBody>
       </p:sp>
       <p:sp>
         <p:nvSpPr>
@@ -13657,6 +13997,10 @@
           </a:solidFill>
           <a:ln/>
         </p:spPr>
+        <p:txBody>
+          <a:bodyPr/>
+          <a:p/>
+        </p:txBody>
       </p:sp>
       <p:pic>
         <p:nvPicPr>
@@ -13835,6 +14179,10 @@
             </a:outerShdw>
           </a:effectLst>
         </p:spPr>
+        <p:txBody>
+          <a:bodyPr/>
+          <a:p/>
+        </p:txBody>
       </p:sp>
       <p:sp>
         <p:nvSpPr>
@@ -13855,6 +14203,10 @@
           </a:solidFill>
           <a:ln/>
         </p:spPr>
+        <p:txBody>
+          <a:bodyPr/>
+          <a:p/>
+        </p:txBody>
       </p:sp>
       <p:pic>
         <p:nvPicPr>
@@ -14033,6 +14385,10 @@
             </a:outerShdw>
           </a:effectLst>
         </p:spPr>
+        <p:txBody>
+          <a:bodyPr/>
+          <a:p/>
+        </p:txBody>
       </p:sp>
       <p:sp>
         <p:nvSpPr>
@@ -14053,6 +14409,10 @@
           </a:solidFill>
           <a:ln/>
         </p:spPr>
+        <p:txBody>
+          <a:bodyPr/>
+          <a:p/>
+        </p:txBody>
       </p:sp>
       <p:pic>
         <p:nvPicPr>
@@ -14219,6 +14579,10 @@
           </a:solidFill>
           <a:ln/>
         </p:spPr>
+        <p:txBody>
+          <a:bodyPr/>
+          <a:p/>
+        </p:txBody>
       </p:sp>
       <p:sp>
         <p:nvSpPr>
@@ -14311,6 +14675,10 @@
             <a:prstDash val="solid"/>
           </a:ln>
         </p:spPr>
+        <p:txBody>
+          <a:bodyPr/>
+          <a:p/>
+        </p:txBody>
       </p:sp>
       <p:sp>
         <p:nvSpPr>
@@ -14448,6 +14816,10 @@
           </a:solidFill>
           <a:ln/>
         </p:spPr>
+        <p:txBody>
+          <a:bodyPr/>
+          <a:p/>
+        </p:txBody>
       </p:sp>
       <p:sp>
         <p:nvSpPr>
@@ -14468,6 +14840,10 @@
           </a:solidFill>
           <a:ln/>
         </p:spPr>
+        <p:txBody>
+          <a:bodyPr/>
+          <a:p/>
+        </p:txBody>
       </p:sp>
       <p:sp>
         <p:nvSpPr>
@@ -14488,6 +14864,10 @@
           </a:solidFill>
           <a:ln/>
         </p:spPr>
+        <p:txBody>
+          <a:bodyPr/>
+          <a:p/>
+        </p:txBody>
       </p:sp>
       <p:sp>
         <p:nvSpPr>
@@ -14508,6 +14888,10 @@
           </a:solidFill>
           <a:ln/>
         </p:spPr>
+        <p:txBody>
+          <a:bodyPr/>
+          <a:p/>
+        </p:txBody>
       </p:sp>
       <p:sp>
         <p:nvSpPr>
@@ -14528,6 +14912,10 @@
           </a:solidFill>
           <a:ln/>
         </p:spPr>
+        <p:txBody>
+          <a:bodyPr/>
+          <a:p/>
+        </p:txBody>
       </p:sp>
       <p:sp>
         <p:nvSpPr>
@@ -14550,6 +14938,10 @@
           </a:solidFill>
           <a:ln/>
         </p:spPr>
+        <p:txBody>
+          <a:bodyPr/>
+          <a:p/>
+        </p:txBody>
       </p:sp>
       <p:sp>
         <p:nvSpPr>
@@ -14861,6 +15253,10 @@
             </a:outerShdw>
           </a:effectLst>
         </p:spPr>
+        <p:txBody>
+          <a:bodyPr/>
+          <a:p/>
+        </p:txBody>
       </p:sp>
       <p:sp>
         <p:nvSpPr>
@@ -14920,6 +15316,10 @@
           </a:solidFill>
           <a:ln/>
         </p:spPr>
+        <p:txBody>
+          <a:bodyPr/>
+          <a:p/>
+        </p:txBody>
       </p:sp>
       <p:sp>
         <p:nvSpPr>
@@ -14982,6 +15382,10 @@
           </a:solidFill>
           <a:ln/>
         </p:spPr>
+        <p:txBody>
+          <a:bodyPr/>
+          <a:p/>
+        </p:txBody>
       </p:sp>
       <p:sp>
         <p:nvSpPr>
@@ -15044,6 +15448,10 @@
           </a:solidFill>
           <a:ln/>
         </p:spPr>
+        <p:txBody>
+          <a:bodyPr/>
+          <a:p/>
+        </p:txBody>
       </p:sp>
       <p:sp>
         <p:nvSpPr>
@@ -15106,6 +15514,10 @@
           </a:solidFill>
           <a:ln/>
         </p:spPr>
+        <p:txBody>
+          <a:bodyPr/>
+          <a:p/>
+        </p:txBody>
       </p:sp>
       <p:sp>
         <p:nvSpPr>
@@ -15276,6 +15688,10 @@
             <a:prstDash val="solid"/>
           </a:ln>
         </p:spPr>
+        <p:txBody>
+          <a:bodyPr/>
+          <a:p/>
+        </p:txBody>
       </p:sp>
       <p:sp>
         <p:nvSpPr>
@@ -15413,6 +15829,10 @@
           </a:solidFill>
           <a:ln/>
         </p:spPr>
+        <p:txBody>
+          <a:bodyPr/>
+          <a:p/>
+        </p:txBody>
       </p:sp>
       <p:sp>
         <p:nvSpPr>
@@ -15433,6 +15853,10 @@
           </a:solidFill>
           <a:ln/>
         </p:spPr>
+        <p:txBody>
+          <a:bodyPr/>
+          <a:p/>
+        </p:txBody>
       </p:sp>
       <p:sp>
         <p:nvSpPr>
@@ -15453,6 +15877,10 @@
           </a:solidFill>
           <a:ln/>
         </p:spPr>
+        <p:txBody>
+          <a:bodyPr/>
+          <a:p/>
+        </p:txBody>
       </p:sp>
       <p:sp>
         <p:nvSpPr>
@@ -15473,6 +15901,10 @@
           </a:solidFill>
           <a:ln/>
         </p:spPr>
+        <p:txBody>
+          <a:bodyPr/>
+          <a:p/>
+        </p:txBody>
       </p:sp>
       <p:sp>
         <p:nvSpPr>
@@ -15493,6 +15925,10 @@
           </a:solidFill>
           <a:ln/>
         </p:spPr>
+        <p:txBody>
+          <a:bodyPr/>
+          <a:p/>
+        </p:txBody>
       </p:sp>
       <p:sp>
         <p:nvSpPr>
@@ -15520,6 +15956,10 @@
             <a:prstDash val="solid"/>
           </a:ln>
         </p:spPr>
+        <p:txBody>
+          <a:bodyPr/>
+          <a:p/>
+        </p:txBody>
       </p:sp>
       <p:sp>
         <p:nvSpPr>
@@ -15596,7 +16036,7 @@
                 <a:ea typeface="Calibri" pitchFamily="34" charset="-122"/>
                 <a:cs typeface="Calibri" pitchFamily="34" charset="-120"/>
               </a:rPr>
-              <a:t>Rural clinics are offline. Connectivity is the binding constraint.</a:t>
+              <a:t>Clinics are offline. Connectivity is the binding constraint.</a:t>
             </a:r>
             <a:endParaRPr lang="en-US" sz="1250" dirty="0"/>
           </a:p>
@@ -15623,6 +16063,10 @@
           </a:solidFill>
           <a:ln/>
         </p:spPr>
+        <p:txBody>
+          <a:bodyPr/>
+          <a:p/>
+        </p:txBody>
       </p:sp>
       <p:sp>
         <p:nvSpPr>
@@ -15699,7 +16143,7 @@
                 <a:ea typeface="Calibri" pitchFamily="34" charset="-122"/>
                 <a:cs typeface="Calibri" pitchFamily="34" charset="-120"/>
               </a:rPr>
-              <a:t>83.3% of rural households have internet access, against 91.6% urban — a real gap, but far smaller than we assumed.</a:t>
+              <a:t>Internet access now reaches a large majority of Indian households — the gap is far smaller than we assumed.</a:t>
             </a:r>
             <a:endParaRPr lang="en-US" sz="1250" dirty="0"/>
           </a:p>
@@ -15733,6 +16177,10 @@
             </a:outerShdw>
           </a:effectLst>
         </p:spPr>
+        <p:txBody>
+          <a:bodyPr/>
+          <a:p/>
+        </p:txBody>
       </p:sp>
       <p:sp>
         <p:nvSpPr>
@@ -15919,6 +16367,10 @@
             <a:prstDash val="solid"/>
           </a:ln>
         </p:spPr>
+        <p:txBody>
+          <a:bodyPr/>
+          <a:p/>
+        </p:txBody>
       </p:sp>
       <p:sp>
         <p:nvSpPr>
@@ -16022,6 +16474,10 @@
           </a:solidFill>
           <a:ln/>
         </p:spPr>
+        <p:txBody>
+          <a:bodyPr/>
+          <a:p/>
+        </p:txBody>
       </p:sp>
       <p:sp>
         <p:nvSpPr>
@@ -16132,6 +16588,10 @@
             </a:outerShdw>
           </a:effectLst>
         </p:spPr>
+        <p:txBody>
+          <a:bodyPr/>
+          <a:p/>
+        </p:txBody>
       </p:sp>
       <p:sp>
         <p:nvSpPr>
@@ -16790,7 +17250,7 @@
                 <a:ea typeface="Calibri" pitchFamily="34" charset="-122"/>
                 <a:cs typeface="Calibri" pitchFamily="34" charset="-120"/>
               </a:rPr>
-              <a:t>Solo practitioner · rural India</a:t>
+              <a:t>Practitioner running his own clinic</a:t>
             </a:r>
             <a:endParaRPr lang="en-US" sz="1250" dirty="0"/>
           </a:p>
@@ -17442,6 +17902,10 @@
             <a:prstDash val="solid"/>
           </a:ln>
         </p:spPr>
+        <p:txBody>
+          <a:bodyPr/>
+          <a:p/>
+        </p:txBody>
       </p:sp>
       <p:sp>
         <p:nvSpPr>
@@ -17579,6 +18043,10 @@
           </a:solidFill>
           <a:ln/>
         </p:spPr>
+        <p:txBody>
+          <a:bodyPr/>
+          <a:p/>
+        </p:txBody>
       </p:sp>
       <p:sp>
         <p:nvSpPr>
@@ -17599,6 +18067,10 @@
           </a:solidFill>
           <a:ln/>
         </p:spPr>
+        <p:txBody>
+          <a:bodyPr/>
+          <a:p/>
+        </p:txBody>
       </p:sp>
       <p:sp>
         <p:nvSpPr>
@@ -17619,6 +18091,10 @@
           </a:solidFill>
           <a:ln/>
         </p:spPr>
+        <p:txBody>
+          <a:bodyPr/>
+          <a:p/>
+        </p:txBody>
       </p:sp>
       <p:sp>
         <p:nvSpPr>
@@ -17639,6 +18115,10 @@
           </a:solidFill>
           <a:ln/>
         </p:spPr>
+        <p:txBody>
+          <a:bodyPr/>
+          <a:p/>
+        </p:txBody>
       </p:sp>
       <p:sp>
         <p:nvSpPr>
@@ -17659,6 +18139,10 @@
           </a:solidFill>
           <a:ln/>
         </p:spPr>
+        <p:txBody>
+          <a:bodyPr/>
+          <a:p/>
+        </p:txBody>
       </p:sp>
       <p:sp>
         <p:nvSpPr>
@@ -17681,6 +18165,10 @@
           </a:solidFill>
           <a:ln/>
         </p:spPr>
+        <p:txBody>
+          <a:bodyPr/>
+          <a:p/>
+        </p:txBody>
       </p:sp>
       <p:sp>
         <p:nvSpPr>
@@ -17802,6 +18290,10 @@
           </a:solidFill>
           <a:ln/>
         </p:spPr>
+        <p:txBody>
+          <a:bodyPr/>
+          <a:p/>
+        </p:txBody>
       </p:sp>
       <p:sp>
         <p:nvSpPr>
@@ -17824,6 +18316,10 @@
           </a:solidFill>
           <a:ln/>
         </p:spPr>
+        <p:txBody>
+          <a:bodyPr/>
+          <a:p/>
+        </p:txBody>
       </p:sp>
       <p:sp>
         <p:nvSpPr>
@@ -17945,6 +18441,10 @@
           </a:solidFill>
           <a:ln/>
         </p:spPr>
+        <p:txBody>
+          <a:bodyPr/>
+          <a:p/>
+        </p:txBody>
       </p:sp>
       <p:sp>
         <p:nvSpPr>
@@ -17967,6 +18467,10 @@
           </a:solidFill>
           <a:ln/>
         </p:spPr>
+        <p:txBody>
+          <a:bodyPr/>
+          <a:p/>
+        </p:txBody>
       </p:sp>
       <p:sp>
         <p:nvSpPr>
@@ -18068,6 +18572,10 @@
           </a:solidFill>
           <a:ln/>
         </p:spPr>
+        <p:txBody>
+          <a:bodyPr/>
+          <a:p/>
+        </p:txBody>
       </p:sp>
       <p:sp>
         <p:nvSpPr>
@@ -18090,6 +18598,10 @@
           </a:solidFill>
           <a:ln/>
         </p:spPr>
+        <p:txBody>
+          <a:bodyPr/>
+          <a:p/>
+        </p:txBody>
       </p:sp>
       <p:sp>
         <p:nvSpPr>
@@ -18211,6 +18723,10 @@
           </a:solidFill>
           <a:ln/>
         </p:spPr>
+        <p:txBody>
+          <a:bodyPr/>
+          <a:p/>
+        </p:txBody>
       </p:sp>
       <p:sp>
         <p:nvSpPr>
@@ -18233,6 +18749,10 @@
           </a:solidFill>
           <a:ln/>
         </p:spPr>
+        <p:txBody>
+          <a:bodyPr/>
+          <a:p/>
+        </p:txBody>
       </p:sp>
       <p:sp>
         <p:nvSpPr>
@@ -18354,6 +18874,10 @@
           </a:solidFill>
           <a:ln/>
         </p:spPr>
+        <p:txBody>
+          <a:bodyPr/>
+          <a:p/>
+        </p:txBody>
       </p:sp>
       <p:sp>
         <p:nvSpPr>
@@ -18376,6 +18900,10 @@
           </a:solidFill>
           <a:ln/>
         </p:spPr>
+        <p:txBody>
+          <a:bodyPr/>
+          <a:p/>
+        </p:txBody>
       </p:sp>
       <p:sp>
         <p:nvSpPr>
@@ -18497,6 +19025,10 @@
           </a:solidFill>
           <a:ln/>
         </p:spPr>
+        <p:txBody>
+          <a:bodyPr/>
+          <a:p/>
+        </p:txBody>
       </p:sp>
       <p:sp>
         <p:nvSpPr>
@@ -18559,6 +19091,10 @@
             <a:prstDash val="solid"/>
           </a:ln>
         </p:spPr>
+        <p:txBody>
+          <a:bodyPr/>
+          <a:p/>
+        </p:txBody>
       </p:sp>
       <p:sp>
         <p:nvSpPr>
@@ -18627,6 +19163,10 @@
             </a:outerShdw>
           </a:effectLst>
         </p:spPr>
+        <p:txBody>
+          <a:bodyPr/>
+          <a:p/>
+        </p:txBody>
       </p:sp>
       <p:sp>
         <p:nvSpPr>
@@ -18758,6 +19298,10 @@
             <a:prstDash val="solid"/>
           </a:ln>
         </p:spPr>
+        <p:txBody>
+          <a:bodyPr/>
+          <a:p/>
+        </p:txBody>
       </p:sp>
       <p:sp>
         <p:nvSpPr>
@@ -18895,6 +19439,10 @@
           </a:solidFill>
           <a:ln/>
         </p:spPr>
+        <p:txBody>
+          <a:bodyPr/>
+          <a:p/>
+        </p:txBody>
       </p:sp>
       <p:sp>
         <p:nvSpPr>
@@ -18915,6 +19463,10 @@
           </a:solidFill>
           <a:ln/>
         </p:spPr>
+        <p:txBody>
+          <a:bodyPr/>
+          <a:p/>
+        </p:txBody>
       </p:sp>
       <p:sp>
         <p:nvSpPr>
@@ -18935,6 +19487,10 @@
           </a:solidFill>
           <a:ln/>
         </p:spPr>
+        <p:txBody>
+          <a:bodyPr/>
+          <a:p/>
+        </p:txBody>
       </p:sp>
       <p:sp>
         <p:nvSpPr>
@@ -18955,6 +19511,10 @@
           </a:solidFill>
           <a:ln/>
         </p:spPr>
+        <p:txBody>
+          <a:bodyPr/>
+          <a:p/>
+        </p:txBody>
       </p:sp>
       <p:sp>
         <p:nvSpPr>
@@ -18975,6 +19535,10 @@
           </a:solidFill>
           <a:ln/>
         </p:spPr>
+        <p:txBody>
+          <a:bodyPr/>
+          <a:p/>
+        </p:txBody>
       </p:sp>
       <p:sp>
         <p:nvSpPr>
@@ -19048,6 +19612,10 @@
             </a:outerShdw>
           </a:effectLst>
         </p:spPr>
+        <p:txBody>
+          <a:bodyPr/>
+          <a:p/>
+        </p:txBody>
       </p:sp>
       <p:sp>
         <p:nvSpPr>
@@ -19070,6 +19638,10 @@
           </a:solidFill>
           <a:ln/>
         </p:spPr>
+        <p:txBody>
+          <a:bodyPr/>
+          <a:p/>
+        </p:txBody>
       </p:sp>
       <p:sp>
         <p:nvSpPr>
@@ -19224,6 +19796,10 @@
             </a:outerShdw>
           </a:effectLst>
         </p:spPr>
+        <p:txBody>
+          <a:bodyPr/>
+          <a:p/>
+        </p:txBody>
       </p:sp>
       <p:sp>
         <p:nvSpPr>
@@ -19246,6 +19822,10 @@
           </a:solidFill>
           <a:ln/>
         </p:spPr>
+        <p:txBody>
+          <a:bodyPr/>
+          <a:p/>
+        </p:txBody>
       </p:sp>
       <p:sp>
         <p:nvSpPr>
@@ -19400,6 +19980,10 @@
             </a:outerShdw>
           </a:effectLst>
         </p:spPr>
+        <p:txBody>
+          <a:bodyPr/>
+          <a:p/>
+        </p:txBody>
       </p:sp>
       <p:sp>
         <p:nvSpPr>
@@ -19422,6 +20006,10 @@
           </a:solidFill>
           <a:ln/>
         </p:spPr>
+        <p:txBody>
+          <a:bodyPr/>
+          <a:p/>
+        </p:txBody>
       </p:sp>
       <p:sp>
         <p:nvSpPr>
@@ -19576,6 +20164,10 @@
             </a:outerShdw>
           </a:effectLst>
         </p:spPr>
+        <p:txBody>
+          <a:bodyPr/>
+          <a:p/>
+        </p:txBody>
       </p:sp>
       <p:sp>
         <p:nvSpPr>
@@ -19598,6 +20190,10 @@
           </a:solidFill>
           <a:ln/>
         </p:spPr>
+        <p:txBody>
+          <a:bodyPr/>
+          <a:p/>
+        </p:txBody>
       </p:sp>
       <p:sp>
         <p:nvSpPr>

</xml_diff>

<commit_message>
Bring every deck and document in artifacts/ up to the current plan
ClinicOS now runs online as a service or on a clinic's own computer, and
grows from single-doctor clinics to hospitals, health systems and
international markets. The decks, the report, the blueprint, the pilot
tracker, the blueprint page and the older PDFs no longer pitch it as an
offline, no-cloud tool for rural clinics or name the first field site.

Co-Authored-By: Claude Opus 5.5 <noreply@anthropic.com>
Claude-Session: https://claude.ai/code/session_012tam43Wrx3VFhnLz3rDLzg
</commit_message>
<xml_diff>
--- a/artifacts/ClinicOS_DesignThinking_Deck.pptx
+++ b/artifacts/ClinicOS_DesignThinking_Deck.pptx
@@ -520,7 +520,7 @@
           <a:p>
             <a:r>
               <a:rPr lang="en-US" dirty="0"/>
-              <a:t>Introduce the setting in one line: a one-room clinic in Krishnanagar. This deck walks the five design-thinking stages in order, and each stage changed something about what we built.</a:t>
+              <a:t>Introduce the setting in one line: the outpatient consultation, starting with the single-doctor clinic and growing to hospitals and health systems. This deck walks the five design-thinking stages in order, and each stage changed something about what we built.</a:t>
             </a:r>
             <a:endParaRPr lang="en-US" dirty="0"/>
           </a:p>
@@ -5284,7 +5284,7 @@
                 <a:ea typeface="Calibri" pitchFamily="34" charset="-122"/>
                 <a:cs typeface="Calibri" pitchFamily="34" charset="-120"/>
               </a:rPr>
-              <a:t>Nothing identifiable leaves the machine</a:t>
+              <a:t>Data stays where the clinic chose</a:t>
             </a:r>
             <a:endParaRPr lang="en-US" sz="1300" dirty="0"/>
           </a:p>
@@ -5326,7 +5326,7 @@
                 <a:ea typeface="Calibri" pitchFamily="34" charset="-122"/>
                 <a:cs typeface="Calibri" pitchFamily="34" charset="-120"/>
               </a:rPr>
-              <a:t>no cloud, no upload, no exception</a:t>
+              <a:t>no telemetry, no sharing, no exception</a:t>
             </a:r>
             <a:endParaRPr lang="en-US" sz="1150" dirty="0"/>
           </a:p>
@@ -6379,7 +6379,7 @@
                 <a:ea typeface="Calibri" pitchFamily="34" charset="-122"/>
                 <a:cs typeface="Calibri" pitchFamily="34" charset="-120"/>
               </a:rPr>
-              <a:t>A cloud AI scribe</a:t>
+              <a:t>A scribe locked to one cloud</a:t>
             </a:r>
             <a:endParaRPr lang="en-US" sz="1450" dirty="0"/>
           </a:p>
@@ -6421,7 +6421,7 @@
                 <a:ea typeface="Calibri" pitchFamily="34" charset="-122"/>
                 <a:cs typeface="Calibri" pitchFamily="34" charset="-120"/>
               </a:rPr>
-              <a:t>Sends the most sensitive audio a clinic produces off the premises, and stops working when the link drops.</a:t>
+              <a:t>Gives the clinic no say over where its most sensitive audio goes, and stops working when the link drops.</a:t>
             </a:r>
             <a:endParaRPr lang="en-US" sz="1250" dirty="0"/>
           </a:p>
@@ -6556,7 +6556,7 @@
                 <a:ea typeface="Calibri" pitchFamily="34" charset="-122"/>
                 <a:cs typeface="Calibri" pitchFamily="34" charset="-120"/>
               </a:rPr>
-              <a:t>An on-device ambient scribe</a:t>
+              <a:t>An ambient scribe the clinic controls</a:t>
             </a:r>
             <a:endParaRPr lang="en-US" sz="1450" dirty="0"/>
           </a:p>
@@ -6598,7 +6598,7 @@
                 <a:ea typeface="Calibri" pitchFamily="34" charset="-122"/>
                 <a:cs typeface="Calibri" pitchFamily="34" charset="-120"/>
               </a:rPr>
-              <a:t>Listens to the consultation already happening, drafts the note locally, and asks the doctor only to review and sign.</a:t>
+              <a:t>Listens to the consultation already happening, drafts the note on the clinic's computer or a hosted service it chooses, and asks the doctor only to review and sign.</a:t>
             </a:r>
             <a:endParaRPr lang="en-US" sz="1250" dirty="0"/>
           </a:p>
@@ -8045,7 +8045,7 @@
                 <a:ea typeface="Calibri" pitchFamily="34" charset="-122"/>
                 <a:cs typeface="Calibri" pitchFamily="34" charset="-120"/>
               </a:rPr>
-              <a:t>Runs on an ordinary laptop with no internet connection and no account.</a:t>
+              <a:t>Runs online as a service, or on the clinic's own computer — even without internet.</a:t>
             </a:r>
             <a:endParaRPr lang="en-US" sz="1200" dirty="0"/>
           </a:p>
@@ -8246,7 +8246,7 @@
                 <a:ea typeface="Calibri" pitchFamily="34" charset="-122"/>
                 <a:cs typeface="Calibri" pitchFamily="34" charset="-120"/>
               </a:rPr>
-              <a:t>Audio never leaves the machine</a:t>
+              <a:t>Audio is deleted at signing</a:t>
             </a:r>
             <a:endParaRPr lang="en-US" sz="1350" dirty="0"/>
           </a:p>

</xml_diff>